<commit_message>
docs(final-project): add EKS GitOps screenshots and refresh the CI/CD slide
</commit_message>
<xml_diff>
--- a/demo/CareSlot-presentation.pptx
+++ b/demo/CareSlot-presentation.pptx
@@ -117,32 +117,32 @@
   <p:extLst>
     <p:ext uri="{521415D9-36F7-43E2-AB2F-B90AF26B5E84}">
       <p14:sectionLst xmlns:p14="http://schemas.microsoft.com/office/powerpoint/2010/main">
-        <p14:section name="Introduction" id="{b3de1ecb-3bc6-8375-931f-befaedbc70c4}">
+        <p14:section name="Introduction" id="{100c83b6-b460-f5aa-6d0a-74396f53553e}">
           <p14:sldIdLst>
             <p14:sldId id="256"/>
             <p14:sldId id="257"/>
           </p14:sldIdLst>
         </p14:section>
-        <p14:section name="Build" id="{957e8d14-14b8-d1c4-e52d-d4608b88120e}">
+        <p14:section name="Build" id="{dfe78703-0e53-1bdf-aacc-d3e7bedc289d}">
           <p14:sldIdLst>
             <p14:sldId id="258"/>
             <p14:sldId id="259"/>
           </p14:sldIdLst>
         </p14:section>
-        <p14:section name="Deliver" id="{80e852ec-4538-d596-af07-c860d0c9aec4}">
+        <p14:section name="Deliver" id="{d567ca9b-40b5-b78a-3972-b94d73a482fd}">
           <p14:sldIdLst>
             <p14:sldId id="260"/>
             <p14:sldId id="261"/>
           </p14:sldIdLst>
         </p14:section>
-        <p14:section name="Run" id="{de7a3d7c-c0bb-86b1-b7e4-4b7d88cbe573}">
+        <p14:section name="Run" id="{490e1449-d182-3ef1-425e-0dbd977cb216}">
           <p14:sldIdLst>
             <p14:sldId id="262"/>
             <p14:sldId id="263"/>
             <p14:sldId id="264"/>
           </p14:sldIdLst>
         </p14:section>
-        <p14:section name="Wrap-up" id="{02ca9d3f-c28f-51b3-4439-6d5f123aa9f3}">
+        <p14:section name="Wrap-up" id="{127f7373-388b-f792-8698-49c39e758b88}">
           <p14:sldIdLst>
             <p14:sldId id="265"/>
             <p14:sldId id="266"/>
@@ -7476,7 +7476,7 @@
       </p:sp>
       <p:pic>
         <p:nvPicPr>
-          <p:cNvPr id="37" name="Pipeline screenshot" descr="C:\Users\Asus\AppData\Local\Temp\claude\C--Users-Asus-Documents-3rd-year-term-1-devops-nency-mam\68230852-859c-4662-bacc-99c8e7e44c13\scratchpad\deck\img\m5-pipeline-green.png">    </p:cNvPr>
+          <p:cNvPr id="37" name="Pipeline screenshot" descr="C:\Users\Asus\AppData\Local\Temp\claude\C--Users-Asus-Documents-3rd-year-term-1-devops-nency-mam\68230852-859c-4662-bacc-99c8e7e44c13\scratchpad\deck\img\m5-pipeline-gitops.png">    </p:cNvPr>
           <p:cNvPicPr>
             <a:picLocks noChangeAspect="1"/>
           </p:cNvPicPr>
@@ -7491,7 +7491,7 @@
         <p:spPr>
           <a:xfrm>
             <a:off x="548640" y="3337560"/>
-            <a:ext cx="5120640" cy="2847964"/>
+            <a:ext cx="5120640" cy="2655934"/>
           </a:xfrm>
           <a:prstGeom prst="rect">
             <a:avLst/>

</xml_diff>